<commit_message>
docs(presentation): sync the 4-minute deck containing the real app screenshots
The deck in the NLP folder was regenerated locally with app-1/2/3.png in
ppt-assets, so slide 5 now shows the actual app (Connect Spotify, Choose a
playlist, Ride Mode) instead of placeholders. The repository copy was still the
placeholder version, so it is updated here.

Verified: slide 5 contains 3 pictures; slides 1-4 and 6 unchanged.
</commit_message>
<xml_diff>
--- a/presentation/VoiceRiders-4min.pptx
+++ b/presentation/VoiceRiders-4min.pptx
@@ -8132,47 +8132,30 @@
           </a:p>
         </p:txBody>
       </p:sp>
-      <p:sp>
-        <p:nvSpPr>
-          <p:cNvPr id="12" name="TextBox 11"/>
-          <p:cNvSpPr txBox="1"/>
-          <p:nvPr/>
-        </p:nvSpPr>
-        <p:spPr>
-          <a:xfrm>
-            <a:off x="5943600" y="2834640"/>
-            <a:ext cx="1600200" cy="914400"/>
+      <p:pic>
+        <p:nvPicPr>
+          <p:cNvPr id="12" name="Picture 11" descr="app-1.png"/>
+          <p:cNvPicPr>
+            <a:picLocks noChangeAspect="1"/>
+          </p:cNvPicPr>
+          <p:nvPr/>
+        </p:nvPicPr>
+        <p:blipFill>
+          <a:blip r:embed="rId2"/>
+          <a:stretch>
+            <a:fillRect/>
+          </a:stretch>
+        </p:blipFill>
+        <p:spPr>
+          <a:xfrm>
+            <a:off x="5861303" y="1426464"/>
+            <a:ext cx="1764792" cy="3921760"/>
           </a:xfrm>
           <a:prstGeom prst="rect">
             <a:avLst/>
           </a:prstGeom>
-          <a:noFill/>
-        </p:spPr>
-        <p:txBody>
-          <a:bodyPr wrap="square" anchor="t">
-            <a:spAutoFit/>
-          </a:bodyPr>
-          <a:lstStyle/>
-          <a:p>
-            <a:pPr algn="ctr">
-              <a:lnSpc>
-                <a:spcPct val="120000"/>
-              </a:lnSpc>
-            </a:pPr>
-            <a:r>
-              <a:rPr sz="1100" b="0">
-                <a:solidFill>
-                  <a:srgbClr val="93A1B8"/>
-                </a:solidFill>
-                <a:latin typeface="Segoe UI"/>
-              </a:rPr>
-              <a:t>put
-app-1.png
-here</a:t>
-            </a:r>
-          </a:p>
-        </p:txBody>
-      </p:sp>
+        </p:spPr>
+      </p:pic>
       <p:sp>
         <p:nvSpPr>
           <p:cNvPr id="13" name="TextBox 12"/>
@@ -8256,47 +8239,30 @@
           </a:p>
         </p:txBody>
       </p:sp>
-      <p:sp>
-        <p:nvSpPr>
-          <p:cNvPr id="15" name="TextBox 14"/>
-          <p:cNvSpPr txBox="1"/>
-          <p:nvPr/>
-        </p:nvSpPr>
-        <p:spPr>
-          <a:xfrm>
-            <a:off x="7955280" y="2834640"/>
-            <a:ext cx="1600200" cy="914400"/>
+      <p:pic>
+        <p:nvPicPr>
+          <p:cNvPr id="15" name="Picture 14" descr="app-2.png"/>
+          <p:cNvPicPr>
+            <a:picLocks noChangeAspect="1"/>
+          </p:cNvPicPr>
+          <p:nvPr/>
+        </p:nvPicPr>
+        <p:blipFill>
+          <a:blip r:embed="rId3"/>
+          <a:stretch>
+            <a:fillRect/>
+          </a:stretch>
+        </p:blipFill>
+        <p:spPr>
+          <a:xfrm>
+            <a:off x="7872984" y="1426464"/>
+            <a:ext cx="1764792" cy="3921760"/>
           </a:xfrm>
           <a:prstGeom prst="rect">
             <a:avLst/>
           </a:prstGeom>
-          <a:noFill/>
-        </p:spPr>
-        <p:txBody>
-          <a:bodyPr wrap="square" anchor="t">
-            <a:spAutoFit/>
-          </a:bodyPr>
-          <a:lstStyle/>
-          <a:p>
-            <a:pPr algn="ctr">
-              <a:lnSpc>
-                <a:spcPct val="120000"/>
-              </a:lnSpc>
-            </a:pPr>
-            <a:r>
-              <a:rPr sz="1100" b="0">
-                <a:solidFill>
-                  <a:srgbClr val="93A1B8"/>
-                </a:solidFill>
-                <a:latin typeface="Segoe UI"/>
-              </a:rPr>
-              <a:t>put
-app-2.png
-here</a:t>
-            </a:r>
-          </a:p>
-        </p:txBody>
-      </p:sp>
+        </p:spPr>
+      </p:pic>
       <p:sp>
         <p:nvSpPr>
           <p:cNvPr id="16" name="TextBox 15"/>
@@ -8380,47 +8346,30 @@
           </a:p>
         </p:txBody>
       </p:sp>
-      <p:sp>
-        <p:nvSpPr>
-          <p:cNvPr id="18" name="TextBox 17"/>
-          <p:cNvSpPr txBox="1"/>
-          <p:nvPr/>
-        </p:nvSpPr>
-        <p:spPr>
-          <a:xfrm>
-            <a:off x="9966960" y="2834640"/>
-            <a:ext cx="1600200" cy="914400"/>
+      <p:pic>
+        <p:nvPicPr>
+          <p:cNvPr id="18" name="Picture 17" descr="app-3.png"/>
+          <p:cNvPicPr>
+            <a:picLocks noChangeAspect="1"/>
+          </p:cNvPicPr>
+          <p:nvPr/>
+        </p:nvPicPr>
+        <p:blipFill>
+          <a:blip r:embed="rId4"/>
+          <a:stretch>
+            <a:fillRect/>
+          </a:stretch>
+        </p:blipFill>
+        <p:spPr>
+          <a:xfrm>
+            <a:off x="9884664" y="1426464"/>
+            <a:ext cx="1764792" cy="3921760"/>
           </a:xfrm>
           <a:prstGeom prst="rect">
             <a:avLst/>
           </a:prstGeom>
-          <a:noFill/>
-        </p:spPr>
-        <p:txBody>
-          <a:bodyPr wrap="square" anchor="t">
-            <a:spAutoFit/>
-          </a:bodyPr>
-          <a:lstStyle/>
-          <a:p>
-            <a:pPr algn="ctr">
-              <a:lnSpc>
-                <a:spcPct val="120000"/>
-              </a:lnSpc>
-            </a:pPr>
-            <a:r>
-              <a:rPr sz="1100" b="0">
-                <a:solidFill>
-                  <a:srgbClr val="93A1B8"/>
-                </a:solidFill>
-                <a:latin typeface="Segoe UI"/>
-              </a:rPr>
-              <a:t>put
-app-3.png
-here</a:t>
-            </a:r>
-          </a:p>
-        </p:txBody>
-      </p:sp>
+        </p:spPr>
+      </p:pic>
       <p:sp>
         <p:nvSpPr>
           <p:cNvPr id="19" name="TextBox 18"/>

</xml_diff>